<commit_message>
UPLOAD HTML , CSS , JAVASCRIPT FILES AND ERD
</commit_message>
<xml_diff>
--- a/master.pptx
+++ b/master.pptx
@@ -263,7 +263,7 @@
           <a:p>
             <a:fld id="{6D04C9D4-BC25-4847-BCF0-40F709FD5D28}" type="datetimeFigureOut">
               <a:rPr lang="ar-JO" smtClean="0"/>
-              <a:t>08/04/1448</a:t>
+              <a:t>11/04/1448</a:t>
             </a:fld>
             <a:endParaRPr lang="ar-JO"/>
           </a:p>
@@ -463,7 +463,7 @@
           <a:p>
             <a:fld id="{6D04C9D4-BC25-4847-BCF0-40F709FD5D28}" type="datetimeFigureOut">
               <a:rPr lang="ar-JO" smtClean="0"/>
-              <a:t>08/04/1448</a:t>
+              <a:t>11/04/1448</a:t>
             </a:fld>
             <a:endParaRPr lang="ar-JO"/>
           </a:p>
@@ -673,7 +673,7 @@
           <a:p>
             <a:fld id="{6D04C9D4-BC25-4847-BCF0-40F709FD5D28}" type="datetimeFigureOut">
               <a:rPr lang="ar-JO" smtClean="0"/>
-              <a:t>08/04/1448</a:t>
+              <a:t>11/04/1448</a:t>
             </a:fld>
             <a:endParaRPr lang="ar-JO"/>
           </a:p>
@@ -873,7 +873,7 @@
           <a:p>
             <a:fld id="{6D04C9D4-BC25-4847-BCF0-40F709FD5D28}" type="datetimeFigureOut">
               <a:rPr lang="ar-JO" smtClean="0"/>
-              <a:t>08/04/1448</a:t>
+              <a:t>11/04/1448</a:t>
             </a:fld>
             <a:endParaRPr lang="ar-JO"/>
           </a:p>
@@ -1149,7 +1149,7 @@
           <a:p>
             <a:fld id="{6D04C9D4-BC25-4847-BCF0-40F709FD5D28}" type="datetimeFigureOut">
               <a:rPr lang="ar-JO" smtClean="0"/>
-              <a:t>08/04/1448</a:t>
+              <a:t>11/04/1448</a:t>
             </a:fld>
             <a:endParaRPr lang="ar-JO"/>
           </a:p>
@@ -1417,7 +1417,7 @@
           <a:p>
             <a:fld id="{6D04C9D4-BC25-4847-BCF0-40F709FD5D28}" type="datetimeFigureOut">
               <a:rPr lang="ar-JO" smtClean="0"/>
-              <a:t>08/04/1448</a:t>
+              <a:t>11/04/1448</a:t>
             </a:fld>
             <a:endParaRPr lang="ar-JO"/>
           </a:p>
@@ -1832,7 +1832,7 @@
           <a:p>
             <a:fld id="{6D04C9D4-BC25-4847-BCF0-40F709FD5D28}" type="datetimeFigureOut">
               <a:rPr lang="ar-JO" smtClean="0"/>
-              <a:t>08/04/1448</a:t>
+              <a:t>11/04/1448</a:t>
             </a:fld>
             <a:endParaRPr lang="ar-JO"/>
           </a:p>
@@ -1974,7 +1974,7 @@
           <a:p>
             <a:fld id="{6D04C9D4-BC25-4847-BCF0-40F709FD5D28}" type="datetimeFigureOut">
               <a:rPr lang="ar-JO" smtClean="0"/>
-              <a:t>08/04/1448</a:t>
+              <a:t>11/04/1448</a:t>
             </a:fld>
             <a:endParaRPr lang="ar-JO"/>
           </a:p>
@@ -2087,7 +2087,7 @@
           <a:p>
             <a:fld id="{6D04C9D4-BC25-4847-BCF0-40F709FD5D28}" type="datetimeFigureOut">
               <a:rPr lang="ar-JO" smtClean="0"/>
-              <a:t>08/04/1448</a:t>
+              <a:t>11/04/1448</a:t>
             </a:fld>
             <a:endParaRPr lang="ar-JO"/>
           </a:p>
@@ -2400,7 +2400,7 @@
           <a:p>
             <a:fld id="{6D04C9D4-BC25-4847-BCF0-40F709FD5D28}" type="datetimeFigureOut">
               <a:rPr lang="ar-JO" smtClean="0"/>
-              <a:t>08/04/1448</a:t>
+              <a:t>11/04/1448</a:t>
             </a:fld>
             <a:endParaRPr lang="ar-JO"/>
           </a:p>
@@ -2689,7 +2689,7 @@
           <a:p>
             <a:fld id="{6D04C9D4-BC25-4847-BCF0-40F709FD5D28}" type="datetimeFigureOut">
               <a:rPr lang="ar-JO" smtClean="0"/>
-              <a:t>08/04/1448</a:t>
+              <a:t>11/04/1448</a:t>
             </a:fld>
             <a:endParaRPr lang="ar-JO"/>
           </a:p>
@@ -2932,7 +2932,7 @@
           <a:p>
             <a:fld id="{6D04C9D4-BC25-4847-BCF0-40F709FD5D28}" type="datetimeFigureOut">
               <a:rPr lang="ar-JO" smtClean="0"/>
-              <a:t>08/04/1448</a:t>
+              <a:t>11/04/1448</a:t>
             </a:fld>
             <a:endParaRPr lang="ar-JO"/>
           </a:p>
@@ -3538,6 +3538,35 @@
             </a:r>
           </a:p>
           <a:p>
+            <a:pPr lvl="0" algn="l"/>
+            <a:r>
+              <a:rPr lang="ar-JO" sz="4800" dirty="0"/>
+              <a:t>حجز زيارات للمختصين في الدعم </a:t>
+            </a:r>
+          </a:p>
+          <a:p>
+            <a:pPr lvl="0" algn="l"/>
+            <a:r>
+              <a:rPr lang="ar-JO" sz="4800" dirty="0"/>
+              <a:t>اقتراح اماكن قريبة وامكانية حجزها</a:t>
+            </a:r>
+          </a:p>
+          <a:p>
+            <a:pPr lvl="0" algn="l"/>
+            <a:r>
+              <a:rPr lang="ar-JO" sz="4800" dirty="0"/>
+              <a:t>ال </a:t>
+            </a:r>
+            <a:r>
+              <a:rPr lang="en-US" sz="4800" dirty="0"/>
+              <a:t>ai </a:t>
+            </a:r>
+            <a:r>
+              <a:rPr lang="ar-JO" sz="4800" dirty="0"/>
+              <a:t>يعمملي خطة محددة </a:t>
+            </a:r>
+          </a:p>
+          <a:p>
             <a:pPr algn="l"/>
             <a:r>
               <a:rPr lang="ar-JO" sz="4800" b="1" dirty="0"/>

</xml_diff>